<commit_message>
Fix PPTX highlight overlap with drawn highlight shapes; add Poppins font pack
Co-Authored-By: Claude Sonnet 5.5 <noreply@anthropic.com>
Claude-Session: https://claude.ai/code/session_013RWrZY7Vk6d3R8BExQoLnL
</commit_message>
<xml_diff>
--- a/carousel-output/C01-sehat-vs-gak-sakit/C01.pptx
+++ b/carousel-output/C01-sehat-vs-gak-sakit/C01.pptx
@@ -4484,7 +4484,39 @@
       </p:sp>
       <p:sp>
         <p:nvSpPr>
-          <p:cNvPr id="6" name="TextBox 5"/>
+          <p:cNvPr id="6" name="Highlight"/>
+          <p:cNvSpPr/>
+          <p:nvPr/>
+        </p:nvSpPr>
+        <p:spPr>
+          <a:xfrm>
+            <a:off x="3037582" y="5155978"/>
+            <a:ext cx="3372892" cy="1010412"/>
+          </a:xfrm>
+          <a:prstGeom prst="roundRect">
+            <a:avLst>
+              <a:gd name="adj" fmla="val 19607"/>
+            </a:avLst>
+          </a:prstGeom>
+          <a:solidFill>
+            <a:srgbClr val="4B7B98"/>
+          </a:solidFill>
+          <a:ln>
+            <a:noFill/>
+          </a:ln>
+          <a:effectLst/>
+        </p:spPr>
+        <p:txBody>
+          <a:bodyPr rtlCol="0" anchor="ctr"/>
+          <a:lstStyle/>
+          <a:p>
+            <a:pPr algn="ctr"/>
+          </a:p>
+        </p:txBody>
+      </p:sp>
+      <p:sp>
+        <p:nvSpPr>
+          <p:cNvPr id="7" name="Teks"/>
           <p:cNvSpPr txBox="1"/>
           <p:nvPr/>
         </p:nvSpPr>
@@ -4514,21 +4546,9 @@
                 <a:solidFill>
                   <a:srgbClr val="FFFFFF"/>
                 </a:solidFill>
-                <a:highlight>
-                  <a:srgbClr val="4B7B98"/>
-                </a:highlight>
                 <a:latin typeface="Poppins ExtraBold"/>
               </a:rPr>
-              <a:t> Sehat </a:t>
-            </a:r>
-            <a:r>
-              <a:rPr b="0" i="0" sz="7800">
-                <a:solidFill>
-                  <a:srgbClr val="FFFFFF"/>
-                </a:solidFill>
-                <a:latin typeface="Poppins ExtraBold"/>
-              </a:rPr>
-              <a:t> ≠</a:t>
+              <a:t> Sehat  ≠</a:t>
             </a:r>
             <a:br/>
             <a:r>
@@ -4555,7 +4575,7 @@
       </p:sp>
       <p:sp>
         <p:nvSpPr>
-          <p:cNvPr id="7" name="TextBox 6"/>
+          <p:cNvPr id="8" name="TextBox 7"/>
           <p:cNvSpPr txBox="1"/>
           <p:nvPr/>
         </p:nvSpPr>
@@ -4604,7 +4624,7 @@
       </p:sp>
       <p:sp>
         <p:nvSpPr>
-          <p:cNvPr id="8" name="Panah next (cincin)"/>
+          <p:cNvPr id="9" name="Panah next (cincin)"/>
           <p:cNvSpPr/>
           <p:nvPr/>
         </p:nvSpPr>
@@ -4634,7 +4654,7 @@
       </p:sp>
       <p:sp>
         <p:nvSpPr>
-          <p:cNvPr id="9" name="Panah next"/>
+          <p:cNvPr id="10" name="Panah next"/>
           <p:cNvSpPr/>
           <p:nvPr/>
         </p:nvSpPr>
@@ -5030,7 +5050,7 @@
                               <p:par>
                                 <p:cTn id="26" presetID="42" presetClass="entr" presetSubtype="0" fill="hold" grpId="0" nodeType="withEffect">
                                   <p:stCondLst>
-                                    <p:cond delay="800"/>
+                                    <p:cond delay="400"/>
                                   </p:stCondLst>
                                   <p:childTnLst>
                                     <p:set>
@@ -5086,9 +5106,9 @@
                                 </p:cTn>
                               </p:par>
                               <p:par>
-                                <p:cTn id="30" presetID="10" presetClass="entr" presetSubtype="0" fill="hold" grpId="0" nodeType="withEffect">
+                                <p:cTn id="30" presetID="42" presetClass="entr" presetSubtype="0" fill="hold" grpId="0" nodeType="withEffect">
                                   <p:stCondLst>
-                                    <p:cond delay="1600"/>
+                                    <p:cond delay="800"/>
                                   </p:stCondLst>
                                   <p:childTnLst>
                                     <p:set>
@@ -5111,24 +5131,47 @@
                                     </p:set>
                                     <p:animEffect transition="in" filter="fade">
                                       <p:cBhvr>
-                                        <p:cTn id="32" dur="500"/>
+                                        <p:cTn id="32" dur="700"/>
                                         <p:tgtEl>
                                           <p:spTgt spid="8"/>
                                         </p:tgtEl>
                                       </p:cBhvr>
                                     </p:animEffect>
+                                    <p:anim calcmode="lin" valueType="num">
+                                      <p:cBhvr additive="base">
+                                        <p:cTn id="33" dur="700" fill="hold"/>
+                                        <p:tgtEl>
+                                          <p:spTgt spid="8"/>
+                                        </p:tgtEl>
+                                        <p:attrNameLst>
+                                          <p:attrName>ppt_y</p:attrName>
+                                        </p:attrNameLst>
+                                      </p:cBhvr>
+                                      <p:tavLst>
+                                        <p:tav tm="0">
+                                          <p:val>
+                                            <p:strVal val="#ppt_y+.04"/>
+                                          </p:val>
+                                        </p:tav>
+                                        <p:tav tm="100000">
+                                          <p:val>
+                                            <p:strVal val="#ppt_y"/>
+                                          </p:val>
+                                        </p:tav>
+                                      </p:tavLst>
+                                    </p:anim>
                                   </p:childTnLst>
                                 </p:cTn>
                               </p:par>
                               <p:par>
-                                <p:cTn id="33" presetID="10" presetClass="entr" presetSubtype="0" fill="hold" grpId="0" nodeType="withEffect">
+                                <p:cTn id="34" presetID="10" presetClass="entr" presetSubtype="0" fill="hold" grpId="0" nodeType="withEffect">
                                   <p:stCondLst>
                                     <p:cond delay="1600"/>
                                   </p:stCondLst>
                                   <p:childTnLst>
                                     <p:set>
                                       <p:cBhvr>
-                                        <p:cTn id="34" dur="1" fill="hold">
+                                        <p:cTn id="35" dur="1" fill="hold">
                                           <p:stCondLst>
                                             <p:cond delay="0"/>
                                           </p:stCondLst>
@@ -5146,9 +5189,44 @@
                                     </p:set>
                                     <p:animEffect transition="in" filter="fade">
                                       <p:cBhvr>
-                                        <p:cTn id="35" dur="500"/>
+                                        <p:cTn id="36" dur="500"/>
                                         <p:tgtEl>
                                           <p:spTgt spid="9"/>
+                                        </p:tgtEl>
+                                      </p:cBhvr>
+                                    </p:animEffect>
+                                  </p:childTnLst>
+                                </p:cTn>
+                              </p:par>
+                              <p:par>
+                                <p:cTn id="37" presetID="10" presetClass="entr" presetSubtype="0" fill="hold" grpId="0" nodeType="withEffect">
+                                  <p:stCondLst>
+                                    <p:cond delay="1600"/>
+                                  </p:stCondLst>
+                                  <p:childTnLst>
+                                    <p:set>
+                                      <p:cBhvr>
+                                        <p:cTn id="38" dur="1" fill="hold">
+                                          <p:stCondLst>
+                                            <p:cond delay="0"/>
+                                          </p:stCondLst>
+                                        </p:cTn>
+                                        <p:tgtEl>
+                                          <p:spTgt spid="10"/>
+                                        </p:tgtEl>
+                                        <p:attrNameLst>
+                                          <p:attrName>style.visibility</p:attrName>
+                                        </p:attrNameLst>
+                                      </p:cBhvr>
+                                      <p:to>
+                                        <p:strVal val="visible"/>
+                                      </p:to>
+                                    </p:set>
+                                    <p:animEffect transition="in" filter="fade">
+                                      <p:cBhvr>
+                                        <p:cTn id="39" dur="500"/>
+                                        <p:tgtEl>
+                                          <p:spTgt spid="10"/>
                                         </p:tgtEl>
                                       </p:cBhvr>
                                     </p:animEffect>
@@ -5191,6 +5269,7 @@
       <p:bldP spid="7" grpId="0" animBg="1"/>
       <p:bldP spid="8" grpId="0" animBg="1"/>
       <p:bldP spid="9" grpId="0" animBg="1"/>
+      <p:bldP spid="10" grpId="0" animBg="1"/>
     </p:bldLst>
   </p:timing>
 </p:sld>
@@ -5935,7 +6014,39 @@
       </p:sp>
       <p:sp>
         <p:nvSpPr>
-          <p:cNvPr id="4" name="TextBox 3"/>
+          <p:cNvPr id="4" name="Highlight"/>
+          <p:cNvSpPr/>
+          <p:nvPr/>
+        </p:nvSpPr>
+        <p:spPr>
+          <a:xfrm>
+            <a:off x="762000" y="7201662"/>
+            <a:ext cx="6903988" cy="854964"/>
+          </a:xfrm>
+          <a:prstGeom prst="roundRect">
+            <a:avLst>
+              <a:gd name="adj" fmla="val 19607"/>
+            </a:avLst>
+          </a:prstGeom>
+          <a:solidFill>
+            <a:srgbClr val="AB2224"/>
+          </a:solidFill>
+          <a:ln>
+            <a:noFill/>
+          </a:ln>
+          <a:effectLst/>
+        </p:spPr>
+        <p:txBody>
+          <a:bodyPr rtlCol="0" anchor="ctr"/>
+          <a:lstStyle/>
+          <a:p>
+            <a:pPr algn="ctr"/>
+          </a:p>
+        </p:txBody>
+      </p:sp>
+      <p:sp>
+        <p:nvSpPr>
+          <p:cNvPr id="5" name="Teks"/>
           <p:cNvSpPr txBox="1"/>
           <p:nvPr/>
         </p:nvSpPr>
@@ -5975,9 +6086,6 @@
                 <a:solidFill>
                   <a:srgbClr val="FFFFFF"/>
                 </a:solidFill>
-                <a:highlight>
-                  <a:srgbClr val="AB2224"/>
-                </a:highlight>
                 <a:latin typeface="Poppins ExtraBold"/>
               </a:rPr>
               <a:t> ngerasa cukup </a:t>
@@ -5987,7 +6095,7 @@
       </p:sp>
       <p:sp>
         <p:nvSpPr>
-          <p:cNvPr id="5" name="TextBox 4"/>
+          <p:cNvPr id="6" name="TextBox 5"/>
           <p:cNvSpPr txBox="1"/>
           <p:nvPr/>
         </p:nvSpPr>
@@ -6026,7 +6134,7 @@
       </p:sp>
       <p:sp>
         <p:nvSpPr>
-          <p:cNvPr id="6" name="Panah next (cincin)"/>
+          <p:cNvPr id="7" name="Panah next (cincin)"/>
           <p:cNvSpPr/>
           <p:nvPr/>
         </p:nvSpPr>
@@ -6056,7 +6164,7 @@
       </p:sp>
       <p:sp>
         <p:nvSpPr>
-          <p:cNvPr id="7" name="Panah next"/>
+          <p:cNvPr id="8" name="Panah next"/>
           <p:cNvSpPr/>
           <p:nvPr/>
         </p:nvSpPr>
@@ -6313,7 +6421,7 @@
                               <p:par>
                                 <p:cTn id="17" presetID="42" presetClass="entr" presetSubtype="0" fill="hold" grpId="0" nodeType="withEffect">
                                   <p:stCondLst>
-                                    <p:cond delay="800"/>
+                                    <p:cond delay="500"/>
                                   </p:stCondLst>
                                   <p:childTnLst>
                                     <p:set>
@@ -6369,9 +6477,9 @@
                                 </p:cTn>
                               </p:par>
                               <p:par>
-                                <p:cTn id="21" presetID="10" presetClass="entr" presetSubtype="0" fill="hold" grpId="0" nodeType="withEffect">
+                                <p:cTn id="21" presetID="42" presetClass="entr" presetSubtype="0" fill="hold" grpId="0" nodeType="withEffect">
                                   <p:stCondLst>
-                                    <p:cond delay="1600"/>
+                                    <p:cond delay="800"/>
                                   </p:stCondLst>
                                   <p:childTnLst>
                                     <p:set>
@@ -6394,24 +6502,47 @@
                                     </p:set>
                                     <p:animEffect transition="in" filter="fade">
                                       <p:cBhvr>
-                                        <p:cTn id="23" dur="500"/>
+                                        <p:cTn id="23" dur="700"/>
                                         <p:tgtEl>
                                           <p:spTgt spid="6"/>
                                         </p:tgtEl>
                                       </p:cBhvr>
                                     </p:animEffect>
+                                    <p:anim calcmode="lin" valueType="num">
+                                      <p:cBhvr additive="base">
+                                        <p:cTn id="24" dur="700" fill="hold"/>
+                                        <p:tgtEl>
+                                          <p:spTgt spid="6"/>
+                                        </p:tgtEl>
+                                        <p:attrNameLst>
+                                          <p:attrName>ppt_y</p:attrName>
+                                        </p:attrNameLst>
+                                      </p:cBhvr>
+                                      <p:tavLst>
+                                        <p:tav tm="0">
+                                          <p:val>
+                                            <p:strVal val="#ppt_y+.04"/>
+                                          </p:val>
+                                        </p:tav>
+                                        <p:tav tm="100000">
+                                          <p:val>
+                                            <p:strVal val="#ppt_y"/>
+                                          </p:val>
+                                        </p:tav>
+                                      </p:tavLst>
+                                    </p:anim>
                                   </p:childTnLst>
                                 </p:cTn>
                               </p:par>
                               <p:par>
-                                <p:cTn id="24" presetID="10" presetClass="entr" presetSubtype="0" fill="hold" grpId="0" nodeType="withEffect">
+                                <p:cTn id="25" presetID="10" presetClass="entr" presetSubtype="0" fill="hold" grpId="0" nodeType="withEffect">
                                   <p:stCondLst>
                                     <p:cond delay="1600"/>
                                   </p:stCondLst>
                                   <p:childTnLst>
                                     <p:set>
                                       <p:cBhvr>
-                                        <p:cTn id="25" dur="1" fill="hold">
+                                        <p:cTn id="26" dur="1" fill="hold">
                                           <p:stCondLst>
                                             <p:cond delay="0"/>
                                           </p:stCondLst>
@@ -6429,9 +6560,44 @@
                                     </p:set>
                                     <p:animEffect transition="in" filter="fade">
                                       <p:cBhvr>
-                                        <p:cTn id="26" dur="500"/>
+                                        <p:cTn id="27" dur="500"/>
                                         <p:tgtEl>
                                           <p:spTgt spid="7"/>
+                                        </p:tgtEl>
+                                      </p:cBhvr>
+                                    </p:animEffect>
+                                  </p:childTnLst>
+                                </p:cTn>
+                              </p:par>
+                              <p:par>
+                                <p:cTn id="28" presetID="10" presetClass="entr" presetSubtype="0" fill="hold" grpId="0" nodeType="withEffect">
+                                  <p:stCondLst>
+                                    <p:cond delay="1600"/>
+                                  </p:stCondLst>
+                                  <p:childTnLst>
+                                    <p:set>
+                                      <p:cBhvr>
+                                        <p:cTn id="29" dur="1" fill="hold">
+                                          <p:stCondLst>
+                                            <p:cond delay="0"/>
+                                          </p:stCondLst>
+                                        </p:cTn>
+                                        <p:tgtEl>
+                                          <p:spTgt spid="8"/>
+                                        </p:tgtEl>
+                                        <p:attrNameLst>
+                                          <p:attrName>style.visibility</p:attrName>
+                                        </p:attrNameLst>
+                                      </p:cBhvr>
+                                      <p:to>
+                                        <p:strVal val="visible"/>
+                                      </p:to>
+                                    </p:set>
+                                    <p:animEffect transition="in" filter="fade">
+                                      <p:cBhvr>
+                                        <p:cTn id="30" dur="500"/>
+                                        <p:tgtEl>
+                                          <p:spTgt spid="8"/>
                                         </p:tgtEl>
                                       </p:cBhvr>
                                     </p:animEffect>
@@ -6472,6 +6638,7 @@
       <p:bldP spid="5" grpId="0" animBg="1"/>
       <p:bldP spid="6" grpId="0" animBg="1"/>
       <p:bldP spid="7" grpId="0" animBg="1"/>
+      <p:bldP spid="8" grpId="0" animBg="1"/>
     </p:bldLst>
   </p:timing>
 </p:sld>

</xml_diff>